<commit_message>
Deploy hub update for Thesilveryouth
</commit_message>
<xml_diff>
--- a/webinar/thesilveryouth-webinar-deck.pptx
+++ b/webinar/thesilveryouth-webinar-deck.pptx
@@ -6727,7 +6727,7 @@
                 </a:solidFill>
                 <a:latin typeface="Arial"/>
               </a:rPr>
-              <a:t>the 90-day system + the room, inside my discord</a:t>
+              <a:t>the 90-day system + the room  ·  founding launch</a:t>
             </a:r>
           </a:p>
           <a:p>
@@ -6743,7 +6743,7 @@
                 </a:solidFill>
                 <a:latin typeface="Arial"/>
               </a:rPr>
-              <a:t>not a new thing i invented tonight. you've been seeing screenshots of it all night.</a:t>
+              <a:t>until now i've only coached 1-1. every screenshot tonight came from that. tonight it opens to a first group.</a:t>
             </a:r>
           </a:p>
         </p:txBody>
@@ -7075,7 +7075,7 @@
                 </a:solidFill>
                 <a:latin typeface="Arial"/>
               </a:rPr>
-              <a:t>bet 90 days on yourself.   ·   [CHECKOUT URL]   ·   founding cohort $[PRICE]</a:t>
+              <a:t>bet 90 days on yourself.   ·   [CHECKOUT URL]   ·   founding cohort $[PRICE]/mo</a:t>
             </a:r>
           </a:p>
         </p:txBody>
@@ -7179,7 +7179,7 @@
                 </a:solidFill>
                 <a:latin typeface="Arial"/>
               </a:rPr>
-              <a:t>the community: the room you saw</a:t>
+              <a:t>the community: the room, opened up</a:t>
             </a:r>
           </a:p>
         </p:txBody>
@@ -7192,8 +7192,8 @@
         </p:nvSpPr>
         <p:spPr>
           <a:xfrm>
-            <a:off x="685800" y="2377440"/>
-            <a:ext cx="10820095" cy="3657600"/>
+            <a:off x="685800" y="2286000"/>
+            <a:ext cx="10820095" cy="3749040"/>
           </a:xfrm>
           <a:prstGeom prst="rect">
             <a:avLst/>
@@ -7208,11 +7208,11 @@
           <a:p>
             <a:pPr algn="l">
               <a:spcAft>
-                <a:spcPts val="1200"/>
-              </a:spcAft>
-            </a:pPr>
-            <a:r>
-              <a:rPr sz="2000" b="0" i="0">
+                <a:spcPts val="1000"/>
+              </a:spcAft>
+            </a:pPr>
+            <a:r>
+              <a:rPr sz="1900" b="0" i="0">
                 <a:solidFill>
                   <a:srgbClr val="1A1A1A"/>
                 </a:solidFill>
@@ -7224,11 +7224,11 @@
           <a:p>
             <a:pPr algn="l">
               <a:spcAft>
-                <a:spcPts val="1200"/>
-              </a:spcAft>
-            </a:pPr>
-            <a:r>
-              <a:rPr sz="2000" b="0" i="0">
+                <a:spcPts val="1000"/>
+              </a:spcAft>
+            </a:pPr>
+            <a:r>
+              <a:rPr sz="1900" b="0" i="0">
                 <a:solidFill>
                   <a:srgbClr val="1A1A1A"/>
                 </a:solidFill>
@@ -7240,33 +7240,49 @@
           <a:p>
             <a:pPr algn="l">
               <a:spcAft>
-                <a:spcPts val="1200"/>
-              </a:spcAft>
-            </a:pPr>
-            <a:r>
-              <a:rPr sz="2000" b="0" i="0">
+                <a:spcPts val="1000"/>
+              </a:spcAft>
+            </a:pPr>
+            <a:r>
+              <a:rPr sz="1900" b="0" i="0">
                 <a:solidFill>
                   <a:srgbClr val="1A1A1A"/>
                 </a:solidFill>
                 <a:latin typeface="Arial"/>
               </a:rPr>
-              <a:t>•  wins channel:  grace's screenshot came from there</a:t>
-            </a:r>
-          </a:p>
-          <a:p>
-            <a:pPr algn="l">
-              <a:spcAft>
-                <a:spcPts val="1200"/>
-              </a:spcAft>
-            </a:pPr>
-            <a:r>
-              <a:rPr sz="2000" b="0" i="0">
+              <a:t>•  wins channel:  where grace's screenshot goes the day it happens</a:t>
+            </a:r>
+          </a:p>
+          <a:p>
+            <a:pPr algn="l">
+              <a:spcAft>
+                <a:spcPts val="1000"/>
+              </a:spcAft>
+            </a:pPr>
+            <a:r>
+              <a:rPr sz="1900" b="0" i="0">
                 <a:solidFill>
                   <a:srgbClr val="1A1A1A"/>
                 </a:solidFill>
                 <a:latin typeface="Arial"/>
               </a:rPr>
               <a:t>•  me, in there, every day</a:t>
+            </a:r>
+          </a:p>
+          <a:p>
+            <a:pPr algn="l">
+              <a:spcAft>
+                <a:spcPts val="1000"/>
+              </a:spcAft>
+            </a:pPr>
+            <a:r>
+              <a:rPr sz="1900" b="0" i="0">
+                <a:solidFill>
+                  <a:srgbClr val="1A1A1A"/>
+                </a:solidFill>
+                <a:latin typeface="Arial"/>
+              </a:rPr>
+              <a:t>•  founding members: the students you just saw, in from day one  [CONFIRM]</a:t>
             </a:r>
           </a:p>
         </p:txBody>
@@ -7358,7 +7374,7 @@
                 </a:solidFill>
                 <a:latin typeface="Arial"/>
               </a:rPr>
-              <a:t>bet 90 days on yourself.   ·   [CHECKOUT URL]   ·   founding cohort $[PRICE]</a:t>
+              <a:t>bet 90 days on yourself.   ·   [CHECKOUT URL]   ·   founding cohort $[PRICE]/mo</a:t>
             </a:r>
           </a:p>
         </p:txBody>
@@ -7731,7 +7747,7 @@
                 </a:solidFill>
                 <a:latin typeface="Arial"/>
               </a:rPr>
-              <a:t>this isn't that</a:t>
+              <a:t>built for the day i made my bet</a:t>
             </a:r>
           </a:p>
           <a:p>
@@ -7747,7 +7763,7 @@
                 </a:solidFill>
                 <a:latin typeface="Arial"/>
               </a:rPr>
-              <a:t>i built it to be the thing i wish existed the day i made my bet:</a:t>
+              <a:t>the thing i wish existed the day i bet on myself:</a:t>
             </a:r>
           </a:p>
           <a:p>
@@ -7923,28 +7939,44 @@
                 </a:solidFill>
                 <a:latin typeface="Arial"/>
               </a:rPr>
-              <a:t>$[PRICE]</a:t>
+              <a:t>$[PRICE]/mo</a:t>
             </a:r>
           </a:p>
           <a:p>
             <a:pPr algn="ctr">
               <a:spcAft>
-                <a:spcPts val="600"/>
-              </a:spcAft>
-            </a:pPr>
-            <a:r>
-              <a:rPr sz="2600" b="1" i="0">
+                <a:spcPts val="400"/>
+              </a:spcAft>
+            </a:pPr>
+            <a:r>
+              <a:rPr sz="2400" b="1" i="0">
                 <a:solidFill>
                   <a:srgbClr val="1A1A1A"/>
                 </a:solidFill>
                 <a:latin typeface="Arial"/>
               </a:rPr>
-              <a:t>one small deal covers it. dev's first was $300.</a:t>
+              <a:t>founding price, locked for life while you're in. cancel anytime.</a:t>
             </a:r>
           </a:p>
           <a:p>
             <a:pPr algn="ctr">
               <a:spcAft>
+                <a:spcPts val="400"/>
+              </a:spcAft>
+            </a:pPr>
+            <a:r>
+              <a:rPr sz="2000" b="0" i="0">
+                <a:solidFill>
+                  <a:srgbClr val="3A3530"/>
+                </a:solidFill>
+                <a:latin typeface="Arial"/>
+              </a:rPr>
+              <a:t>one small deal covers months. dev's first was $300.</a:t>
+            </a:r>
+          </a:p>
+          <a:p>
+            <a:pPr algn="ctr">
+              <a:spcAft>
                 <a:spcPts val="0"/>
               </a:spcAft>
             </a:pPr>
@@ -7955,7 +7987,7 @@
                 </a:solidFill>
                 <a:latin typeface="Arial"/>
               </a:rPr>
-              <a:t>[keep this line only if price ≤ $300]</a:t>
+              <a:t>[keep the deal line only if founding price ≤ $99/mo]</a:t>
             </a:r>
           </a:p>
         </p:txBody>
@@ -8063,7 +8095,7 @@
                 </a:solidFill>
                 <a:latin typeface="Arial"/>
               </a:rPr>
-              <a:t>bet 90 days on yourself.   ·   [CHECKOUT URL]   ·   founding cohort $[PRICE]</a:t>
+              <a:t>bet 90 days on yourself.   ·   [CHECKOUT URL]   ·   founding cohort $[PRICE]/mo</a:t>
             </a:r>
           </a:p>
         </p:txBody>
@@ -8331,7 +8363,7 @@
                 </a:solidFill>
                 <a:latin typeface="Arial"/>
               </a:rPr>
-              <a:t>bet 90 days on yourself.   ·   [CHECKOUT URL]   ·   founding cohort $[PRICE]</a:t>
+              <a:t>bet 90 days on yourself.   ·   [CHECKOUT URL]   ·   founding cohort $[PRICE]/mo</a:t>
             </a:r>
           </a:p>
         </p:txBody>
@@ -8615,7 +8647,7 @@
                 </a:solidFill>
                 <a:latin typeface="Arial"/>
               </a:rPr>
-              <a:t>bet 90 days on yourself.   ·   [CHECKOUT URL]   ·   founding cohort $[PRICE]</a:t>
+              <a:t>bet 90 days on yourself.   ·   [CHECKOUT URL]   ·   founding cohort $[PRICE]/mo</a:t>
             </a:r>
           </a:p>
         </p:txBody>
@@ -8829,7 +8861,7 @@
                 </a:solidFill>
                 <a:latin typeface="Arial"/>
               </a:rPr>
-              <a:t>no fake ten-thousand-dollar value math. it's everything i actually used, in one place, for $[PRICE].</a:t>
+              <a:t>no fake ten-thousand-dollar value math. it's everything i actually used, in one place, for $[PRICE]/mo.</a:t>
             </a:r>
           </a:p>
         </p:txBody>
@@ -8882,7 +8914,7 @@
                 </a:solidFill>
                 <a:latin typeface="Arial"/>
               </a:rPr>
-              <a:t>bet 90 days on yourself.   ·   [CHECKOUT URL]   ·   founding cohort $[PRICE]</a:t>
+              <a:t>bet 90 days on yourself.   ·   [CHECKOUT URL]   ·   founding cohort $[PRICE]/mo</a:t>
             </a:r>
           </a:p>
         </p:txBody>
@@ -9084,13 +9116,13 @@
               </a:spcAft>
             </a:pPr>
             <a:r>
-              <a:rPr sz="1300" b="0" i="1">
-                <a:solidFill>
-                  <a:srgbClr val="8A8A8A"/>
-                </a:solidFill>
-                <a:latin typeface="Arial"/>
-              </a:rPr>
-              <a:t>[fallback if no refunds: monthly billing, cancel anytime]</a:t>
+              <a:rPr sz="1500" b="0" i="1">
+                <a:solidFill>
+                  <a:srgbClr val="3A3530"/>
+                </a:solidFill>
+                <a:latin typeface="Arial"/>
+              </a:rPr>
+              <a:t>and it's monthly: cancel anytime. the only thing keeping you in the room is the room working.</a:t>
             </a:r>
           </a:p>
         </p:txBody>
@@ -9143,7 +9175,7 @@
                 </a:solidFill>
                 <a:latin typeface="Arial"/>
               </a:rPr>
-              <a:t>bet 90 days on yourself.   ·   [CHECKOUT URL]   ·   founding cohort $[PRICE]</a:t>
+              <a:t>bet 90 days on yourself.   ·   [CHECKOUT URL]   ·   founding cohort $[PRICE]/mo</a:t>
             </a:r>
           </a:p>
         </p:txBody>
@@ -9463,7 +9495,7 @@
                 </a:solidFill>
                 <a:latin typeface="Arial"/>
               </a:rPr>
-              <a:t>STUDENTS, THIS MONTH</a:t>
+              <a:t>THE FIRST THREE · FROM THE 1-1</a:t>
             </a:r>
           </a:p>
         </p:txBody>
@@ -9726,7 +9758,7 @@
                 </a:solidFill>
                 <a:latin typeface="Arial"/>
               </a:rPr>
-              <a:t>weeks ago these were people watching videos like you're doing right now.</a:t>
+              <a:t>these three worked with me 1-1. the community is that coaching, opened up.</a:t>
             </a:r>
           </a:p>
         </p:txBody>
@@ -9779,7 +9811,7 @@
                 </a:solidFill>
                 <a:latin typeface="Arial"/>
               </a:rPr>
-              <a:t>bet 90 days on yourself.   ·   [CHECKOUT URL]   ·   founding cohort $[PRICE]</a:t>
+              <a:t>bet 90 days on yourself.   ·   [CHECKOUT URL]   ·   founding cohort $[PRICE]/mo</a:t>
             </a:r>
           </a:p>
         </p:txBody>
@@ -10104,8 +10136,8 @@
         </p:nvSpPr>
         <p:spPr>
           <a:xfrm>
-            <a:off x="685800" y="2743200"/>
-            <a:ext cx="10820095" cy="3291840"/>
+            <a:off x="685800" y="2651760"/>
+            <a:ext cx="10820095" cy="3383280"/>
           </a:xfrm>
           <a:prstGeom prst="rect">
             <a:avLst/>
@@ -10120,27 +10152,27 @@
           <a:p>
             <a:pPr algn="l">
               <a:spcAft>
-                <a:spcPts val="1400"/>
-              </a:spcAft>
-            </a:pPr>
-            <a:r>
-              <a:rPr sz="2100" b="0" i="0">
+                <a:spcPts val="1200"/>
+              </a:spcAft>
+            </a:pPr>
+            <a:r>
+              <a:rPr sz="2000" b="0" i="0">
                 <a:solidFill>
                   <a:srgbClr val="1A1A1A"/>
                 </a:solidFill>
                 <a:latin typeface="Arial"/>
               </a:rPr>
-              <a:t>•  the founding price is tonight's price</a:t>
-            </a:r>
-          </a:p>
-          <a:p>
-            <a:pPr algn="l">
-              <a:spcAft>
-                <a:spcPts val="1400"/>
-              </a:spcAft>
-            </a:pPr>
-            <a:r>
-              <a:rPr sz="2100" b="0" i="0">
+              <a:t>•  founding price locked for life, for as long as you stay</a:t>
+            </a:r>
+          </a:p>
+          <a:p>
+            <a:pPr algn="l">
+              <a:spcAft>
+                <a:spcPts val="1200"/>
+              </a:spcAft>
+            </a:pPr>
+            <a:r>
+              <a:rPr sz="2000" b="0" i="0">
                 <a:solidFill>
                   <a:srgbClr val="1A1A1A"/>
                 </a:solidFill>
@@ -10152,16 +10184,32 @@
           <a:p>
             <a:pPr algn="l">
               <a:spcAft>
-                <a:spcPts val="1400"/>
-              </a:spcAft>
-            </a:pPr>
-            <a:r>
-              <a:rPr sz="2100" b="0" i="0">
+                <a:spcPts val="1200"/>
+              </a:spcAft>
+            </a:pPr>
+            <a:r>
+              <a:rPr sz="2000" b="0" i="0">
                 <a:solidFill>
                   <a:srgbClr val="1A1A1A"/>
                 </a:solidFill>
                 <a:latin typeface="Arial"/>
               </a:rPr>
+              <a:t>•  founding badge: the room will always know you were here when it started</a:t>
+            </a:r>
+          </a:p>
+          <a:p>
+            <a:pPr algn="l">
+              <a:spcAft>
+                <a:spcPts val="1200"/>
+              </a:spcAft>
+            </a:pPr>
+            <a:r>
+              <a:rPr sz="2000" b="0" i="0">
+                <a:solidFill>
+                  <a:srgbClr val="1A1A1A"/>
+                </a:solidFill>
+                <a:latin typeface="Arial"/>
+              </a:rPr>
               <a:t>•  the first cohort starts week 0 together, monday</a:t>
             </a:r>
           </a:p>
@@ -10169,7 +10217,62 @@
       </p:sp>
       <p:sp>
         <p:nvSpPr>
-          <p:cNvPr id="6" name="Rectangle 5"/>
+          <p:cNvPr id="6" name="Rounded Rectangle 5"/>
+          <p:cNvSpPr/>
+          <p:nvPr/>
+        </p:nvSpPr>
+        <p:spPr>
+          <a:xfrm>
+            <a:off x="4041648" y="5120640"/>
+            <a:ext cx="4114800" cy="548640"/>
+          </a:xfrm>
+          <a:prstGeom prst="roundRect">
+            <a:avLst>
+              <a:gd name="adj" fmla="val 50000"/>
+            </a:avLst>
+          </a:prstGeom>
+          <a:solidFill>
+            <a:srgbClr val="8B5A3C"/>
+          </a:solidFill>
+          <a:ln>
+            <a:noFill/>
+          </a:ln>
+          <a:effectLst/>
+        </p:spPr>
+        <p:style>
+          <a:lnRef idx="1">
+            <a:schemeClr val="accent1"/>
+          </a:lnRef>
+          <a:fillRef idx="3">
+            <a:schemeClr val="accent1"/>
+          </a:fillRef>
+          <a:effectRef idx="2">
+            <a:schemeClr val="accent1"/>
+          </a:effectRef>
+          <a:fontRef idx="minor">
+            <a:schemeClr val="lt1"/>
+          </a:fontRef>
+        </p:style>
+        <p:txBody>
+          <a:bodyPr rtlCol="0" anchor="ctr" wrap="none"/>
+          <a:lstStyle/>
+          <a:p>
+            <a:pPr algn="ctr"/>
+            <a:r>
+              <a:rPr sz="1600" b="1">
+                <a:solidFill>
+                  <a:srgbClr val="F4F0E8"/>
+                </a:solidFill>
+                <a:latin typeface="Arial"/>
+              </a:rPr>
+              <a:t>founding · locked for life</a:t>
+            </a:r>
+          </a:p>
+        </p:txBody>
+      </p:sp>
+      <p:sp>
+        <p:nvSpPr>
+          <p:cNvPr id="7" name="Rectangle 6"/>
           <p:cNvSpPr/>
           <p:nvPr/>
         </p:nvSpPr>
@@ -10215,7 +10318,7 @@
                 </a:solidFill>
                 <a:latin typeface="Arial"/>
               </a:rPr>
-              <a:t>bet 90 days on yourself.   ·   [CHECKOUT URL]   ·   founding cohort $[PRICE]</a:t>
+              <a:t>bet 90 days on yourself.   ·   [CHECKOUT URL]   ·   founding cohort $[PRICE]/mo</a:t>
             </a:r>
           </a:p>
         </p:txBody>
@@ -10390,7 +10493,7 @@
                 </a:solidFill>
                 <a:latin typeface="Arial"/>
               </a:rPr>
-              <a:t>2.  join the silver youth ($[PRICE], founding)</a:t>
+              <a:t>2.  join the silver youth ($[PRICE]/mo, founding)</a:t>
             </a:r>
           </a:p>
         </p:txBody>
@@ -10445,7 +10548,7 @@
                 </a:solidFill>
                 <a:latin typeface="Arial"/>
               </a:rPr>
-              <a:t>3.  post your week-0 video in the reps channel tonight</a:t>
+              <a:t>3.  you're in the discord in two minutes. post your week-0 video tonight</a:t>
             </a:r>
           </a:p>
         </p:txBody>
@@ -10674,7 +10777,7 @@
                 </a:solidFill>
                 <a:latin typeface="Arial"/>
               </a:rPr>
-              <a:t>the link stays up   ·   [CHECKOUT URL]   ·   founding cohort $[PRICE]</a:t>
+              <a:t>the link stays up   ·   [CHECKOUT URL]   ·   founding cohort $[PRICE]/mo</a:t>
             </a:r>
           </a:p>
         </p:txBody>

</xml_diff>